<commit_message>
docs(submission): sync materials to E1 dual-channel receipt facts; adopt e7 architecture asset
- M03 $0/2/5.5/5.6/9/10: rebase assembly facts on main 319aa63 (= E1
  source e7fffd61); record PR #96 dd2bf38 as pending-review candidate
  (410 passed / 2 skipped / 15 subtests, not merged into frozen-line
  results); replace stale SMTP-pending wording with the signed E1
  dual-channel receipt (#6 6459911129); honest-untested list refreshed.
- B-DEMO-STEPS: navigation reality (no separate warehouse/batch page),
  dry-run demo boundary, E1 fact kept in A's footage, dated history for
  the 10-27 SSL EOF.
- build-m04: verify tracked CURRENT-ARCHITECTURE-e7.png (PR #89 b4d8c28,
  sha256 pinned) before any output; media part renamed accordingly;
  S1/S6/S7/S8 copy updated to the same facts. Deck rebuilt
  deterministically (two builds same sha256, 8 slides).
- assets: A's e7 current architecture PNG, byte-identical to PR89 head.
</commit_message>
<xml_diff>
--- a/docs/submission/claude-b-materials/M04-PRESENTATION-DRAFT.pptx
+++ b/docs/submission/claude-b-materials/M04-PRESENTATION-DRAFT.pptx
@@ -3094,7 +3094,7 @@
                 <a:latin typeface="Microsoft YaHei"/>
                 <a:ea typeface="Microsoft YaHei"/>
               </a:rPr>
-              <a:t>材料基准：共同 main 319aa63（材料稿；冻结候选确定后逐节复核）</a:t>
+              <a:t>材料基准：共同 main 319aa63（= 一库 E1 实测来源 e7fffd61，全 Git 树一致）</a:t>
             </a:r>
           </a:p>
           <a:p>
@@ -3483,7 +3483,7 @@
         <p:spPr>
           <a:xfrm>
             <a:off x="548640" y="1234440"/>
-            <a:ext cx="6722406" cy="5029200"/>
+            <a:ext cx="6720534" cy="5029200"/>
           </a:xfrm>
           <a:prstGeom prst="rect">
             <a:avLst/>
@@ -3498,8 +3498,8 @@
         </p:nvSpPr>
         <p:spPr>
           <a:xfrm>
-            <a:off x="7545366" y="1463040"/>
-            <a:ext cx="4280874" cy="4572000"/>
+            <a:off x="7543494" y="1463040"/>
+            <a:ext cx="4282746" cy="4572000"/>
           </a:xfrm>
           <a:prstGeom prst="rect">
             <a:avLst/>
@@ -4316,7 +4316,7 @@
                 <a:latin typeface="Microsoft YaHei"/>
                 <a:ea typeface="Microsoft YaHei"/>
               </a:rPr>
-              <a:t>• 飞书手机端：持有人在受控单一事件实测确认实收；SMTP：一次发送遇 SSL 意外 EOF，终端实收待核、未补发</a:t>
+              <a:t>• 一库同版同事件 E1（#6 6459911129）：SMTP 与飞书各一次、两服务接受，队长本人确认邮件与手机飞书均收到、来源 ID 一致（d89c0bf9）</a:t>
             </a:r>
           </a:p>
           <a:p>
@@ -4333,7 +4333,7 @@
                 <a:latin typeface="Microsoft YaHei"/>
                 <a:ea typeface="Microsoft YaHei"/>
               </a:rPr>
-              <a:t>• 服务接受不写成实收；输出字段固定 terminal_receipt_confirmed=False；完整双渠道 E1 未完成</a:t>
+              <a:t>• 服务接受 ≠ 终端实收仍分记；旧 10-27 SSL EOF 为历史未补发；本段演示环境 dry-run，不展示发送画面</a:t>
             </a:r>
           </a:p>
         </p:txBody>
@@ -4459,7 +4459,7 @@
                 <a:latin typeface="Microsoft YaHei"/>
                 <a:ea typeface="Microsoft YaHei"/>
               </a:rPr>
-              <a:t>• 真实 PG 18 / Python 3.14 本机隔离实例（main 319aa63 + PR #96 5fa963c）：告警套件 400 passed / 2 skipped（PG opt-in）/ 15 subtests</a:t>
+              <a:t>• 真实 PG 18 / Python 3.14 本机隔离实例（main 319aa63，= 一库 E1 实测来源 e7fffd61，全树一致）：告警与更正契约 21 条回归已随 main 合入</a:t>
             </a:r>
           </a:p>
           <a:p>
@@ -4476,7 +4476,7 @@
                 <a:latin typeface="Microsoft YaHei"/>
                 <a:ea typeface="Microsoft YaHei"/>
               </a:rPr>
-              <a:t>• 更正契约 21 条回归（含双连接锁交错：更正排队于原异常行锁后不回退并发提交的 resolved），已随 main 319aa63 合入</a:t>
+              <a:t>• PR #96 SMTP 阶段诊断为待审增量（候选历史，不并入冻结主线成绩）：告警套件 410 passed / 2 skipped / 15 subtests</a:t>
             </a:r>
           </a:p>
           <a:p>
@@ -4527,7 +4527,7 @@
                 <a:latin typeface="Microsoft YaHei"/>
                 <a:ea typeface="Microsoft YaHei"/>
               </a:rPr>
-              <a:t>• A45 精确 4792ac3：后端 1216 testcase / 0 失败错误跳过 / 92%；A46 精确 62bb2ef：14 设备组合链见第 4 页</a:t>
+              <a:t>• 一库同版同事件 E1（#6 6459911129）：双渠道终端实收由队长本人确认；浏览器 281 行 14 列 CSV 与 15 页 ID 一致；普通用户 POST 403</a:t>
             </a:r>
           </a:p>
           <a:p>
@@ -4544,7 +4544,7 @@
                 <a:latin typeface="Microsoft YaHei"/>
                 <a:ea typeface="Microsoft YaHei"/>
               </a:rPr>
-              <a:t>• C 第二机（PR #11 精确 0db9402）：默认 CMD/HTTP 与 14 设备分段通过；GuardedRecovery 降温检查两次失败、未最终签收（并列如实）</a:t>
+              <a:t>• C 第二机（干净检出 e7fffd61）：默认 CMD 无源码挂载 HTTP 通过、14 设备夹具；HTTP CSV 10 行 14 列；API 文件 ≠ 浏览器下载（如实）</a:t>
             </a:r>
           </a:p>
           <a:p>
@@ -4561,7 +4561,7 @@
                 <a:latin typeface="Microsoft YaHei"/>
                 <a:ea typeface="Microsoft YaHei"/>
               </a:rPr>
-              <a:t>• A 通知实测：飞书手机端实收由 A 本人确认；SMTP 一次 SSL 意外 EOF、实收待核、未补发（#8 6440797666）</a:t>
+              <a:t>• A 离线入口（PR #95 cdb7d95）：14 在线设备、CSV 15 行全 ID、无网络 PG 重启回读 1202 条</a:t>
             </a:r>
           </a:p>
           <a:p>
@@ -4595,7 +4595,7 @@
                 <a:latin typeface="Microsoft YaHei"/>
                 <a:ea typeface="Microsoft YaHei"/>
               </a:rPr>
-              <a:t>• 以上为隔离回归与受控分段，不是业务现场验收次数；完整同版 E1、最终第二机、SMTP 实收未完成</a:t>
+              <a:t>• 以上为隔离回归与受控分段，不是业务现场验收次数；第二机 180s sustained、浏览器下载核验、最终第二机/M01—M05 总签收未完成；旧 0db9402 失败与旧 10-27 SSL EOF 为有日期历史</a:t>
             </a:r>
           </a:p>
         </p:txBody>
@@ -4721,7 +4721,7 @@
                 <a:latin typeface="Microsoft YaHei"/>
                 <a:ea typeface="Microsoft YaHei"/>
               </a:rPr>
-              <a:t>• 飞书手机实收已确认（A 本人）；SMTP 实收待核未补发；C GuardedRecovery 两次降温检查失败、未最终签收</a:t>
+              <a:t>• 双渠道终端实收已由队长本人在一库同版 E1 确认（#6 6459911129）；E1 出口 ≠ 最终第二机总签收/投稿</a:t>
             </a:r>
           </a:p>
           <a:p>
@@ -4755,7 +4755,7 @@
                 <a:latin typeface="Microsoft YaHei"/>
                 <a:ea typeface="Microsoft YaHei"/>
               </a:rPr>
-              <a:t>• WH1 多批告警评价 hold；模拟数据不宣称真实品质实验；冻结候选后逐节复核</a:t>
+              <a:t>• WH1 多批告警评价 hold；第二机自然持续恢复与浏览器下载核验未测；模拟数据不宣称真实品质实验</a:t>
             </a:r>
           </a:p>
           <a:p>

</xml_diff>